<commit_message>
feat: add pro-tier presentation deck and fix slide overlaps
- Created BeerFlow_Pro_Presentation.pptx (13-slide executive presentation)
  - Yellow-white bold split cover design
  - End-to-end visual logistics pathway journey (Sourcing -> Brewing -> Warehousing -> Logistics -> Distributor -> Retail)
  - Beer mugs clinking/cheers animation transition before data
  - Visual cards for demand, EOQ, logistics network, cold chain & risk, and distributor scorecard
- Fixed slide 7 and slide 8 layout overlaps in BeerFlow_Strategy_Deck.pptx
</commit_message>
<xml_diff>
--- a/powerpoint/BeerFlow_Strategy_Deck.pptx
+++ b/powerpoint/BeerFlow_Strategy_Deck.pptx
@@ -17607,7 +17607,7 @@
         <p:spPr>
           <a:xfrm>
             <a:off x="365760" y="1234440"/>
-            <a:ext cx="5669280" cy="256032"/>
+            <a:ext cx="5486400" cy="256032"/>
           </a:xfrm>
           <a:prstGeom prst="rect">
             <a:avLst/>
@@ -17622,7 +17622,7 @@
           <a:p>
             <a:pPr algn="l"/>
             <a:r>
-              <a:rPr sz="1200" b="1" i="0">
+              <a:rPr sz="1100" b="1" i="0">
                 <a:solidFill>
                   <a:srgbClr val="1F3864"/>
                 </a:solidFill>
@@ -17642,7 +17642,7 @@
         <p:spPr>
           <a:xfrm>
             <a:off x="365760" y="1536192"/>
-            <a:ext cx="2377440" cy="274320"/>
+            <a:ext cx="2286000" cy="274320"/>
           </a:xfrm>
           <a:prstGeom prst="rect">
             <a:avLst/>
@@ -17685,22 +17685,22 @@
         <p:spPr>
           <a:xfrm>
             <a:off x="402336" y="1554480"/>
-            <a:ext cx="2304288" cy="237744"/>
-          </a:xfrm>
-          <a:prstGeom prst="rect">
-            <a:avLst/>
-          </a:prstGeom>
-          <a:noFill/>
-        </p:spPr>
-        <p:txBody>
-          <a:bodyPr wrap="square">
-            <a:spAutoFit/>
-          </a:bodyPr>
-          <a:lstStyle/>
-          <a:p>
-            <a:pPr algn="ctr"/>
-            <a:r>
-              <a:rPr sz="850" b="1" i="0">
+            <a:ext cx="2212848" cy="237744"/>
+          </a:xfrm>
+          <a:prstGeom prst="rect">
+            <a:avLst/>
+          </a:prstGeom>
+          <a:noFill/>
+        </p:spPr>
+        <p:txBody>
+          <a:bodyPr wrap="square">
+            <a:spAutoFit/>
+          </a:bodyPr>
+          <a:lstStyle/>
+          <a:p>
+            <a:pPr algn="ctr"/>
+            <a:r>
+              <a:rPr sz="800" b="1" i="0">
                 <a:solidFill>
                   <a:srgbClr val="FFFFFF"/>
                 </a:solidFill>
@@ -17719,8 +17719,8 @@
         </p:nvSpPr>
         <p:spPr>
           <a:xfrm>
-            <a:off x="2743200" y="1536192"/>
-            <a:ext cx="731520" cy="274320"/>
+            <a:off x="2651760" y="1536192"/>
+            <a:ext cx="685800" cy="274320"/>
           </a:xfrm>
           <a:prstGeom prst="rect">
             <a:avLst/>
@@ -17762,23 +17762,23 @@
         </p:nvSpPr>
         <p:spPr>
           <a:xfrm>
-            <a:off x="2779776" y="1554480"/>
-            <a:ext cx="658368" cy="237744"/>
-          </a:xfrm>
-          <a:prstGeom prst="rect">
-            <a:avLst/>
-          </a:prstGeom>
-          <a:noFill/>
-        </p:spPr>
-        <p:txBody>
-          <a:bodyPr wrap="square">
-            <a:spAutoFit/>
-          </a:bodyPr>
-          <a:lstStyle/>
-          <a:p>
-            <a:pPr algn="ctr"/>
-            <a:r>
-              <a:rPr sz="850" b="1" i="0">
+            <a:off x="2688336" y="1554480"/>
+            <a:ext cx="612648" cy="237744"/>
+          </a:xfrm>
+          <a:prstGeom prst="rect">
+            <a:avLst/>
+          </a:prstGeom>
+          <a:noFill/>
+        </p:spPr>
+        <p:txBody>
+          <a:bodyPr wrap="square">
+            <a:spAutoFit/>
+          </a:bodyPr>
+          <a:lstStyle/>
+          <a:p>
+            <a:pPr algn="ctr"/>
+            <a:r>
+              <a:rPr sz="800" b="1" i="0">
                 <a:solidFill>
                   <a:srgbClr val="FFFFFF"/>
                 </a:solidFill>
@@ -17797,7 +17797,7 @@
         </p:nvSpPr>
         <p:spPr>
           <a:xfrm>
-            <a:off x="3474720" y="1536192"/>
+            <a:off x="3337560" y="1536192"/>
             <a:ext cx="640080" cy="274320"/>
           </a:xfrm>
           <a:prstGeom prst="rect">
@@ -17840,7 +17840,7 @@
         </p:nvSpPr>
         <p:spPr>
           <a:xfrm>
-            <a:off x="3511296" y="1554480"/>
+            <a:off x="3374136" y="1554480"/>
             <a:ext cx="566928" cy="237744"/>
           </a:xfrm>
           <a:prstGeom prst="rect">
@@ -17856,7 +17856,7 @@
           <a:p>
             <a:pPr algn="ctr"/>
             <a:r>
-              <a:rPr sz="850" b="1" i="0">
+              <a:rPr sz="800" b="1" i="0">
                 <a:solidFill>
                   <a:srgbClr val="FFFFFF"/>
                 </a:solidFill>
@@ -17875,7 +17875,7 @@
         </p:nvSpPr>
         <p:spPr>
           <a:xfrm>
-            <a:off x="4114800" y="1536192"/>
+            <a:off x="3977639" y="1536192"/>
             <a:ext cx="640080" cy="274320"/>
           </a:xfrm>
           <a:prstGeom prst="rect">
@@ -17918,7 +17918,7 @@
         </p:nvSpPr>
         <p:spPr>
           <a:xfrm>
-            <a:off x="4151376" y="1554480"/>
+            <a:off x="4014215" y="1554480"/>
             <a:ext cx="566928" cy="237744"/>
           </a:xfrm>
           <a:prstGeom prst="rect">
@@ -17934,7 +17934,7 @@
           <a:p>
             <a:pPr algn="ctr"/>
             <a:r>
-              <a:rPr sz="850" b="1" i="0">
+              <a:rPr sz="800" b="1" i="0">
                 <a:solidFill>
                   <a:srgbClr val="FFFFFF"/>
                 </a:solidFill>
@@ -17953,8 +17953,8 @@
         </p:nvSpPr>
         <p:spPr>
           <a:xfrm>
-            <a:off x="4754880" y="1536192"/>
-            <a:ext cx="1188720" cy="274320"/>
+            <a:off x="4617720" y="1536192"/>
+            <a:ext cx="1417320" cy="274320"/>
           </a:xfrm>
           <a:prstGeom prst="rect">
             <a:avLst/>
@@ -17996,29 +17996,29 @@
         </p:nvSpPr>
         <p:spPr>
           <a:xfrm>
-            <a:off x="4791456" y="1554480"/>
-            <a:ext cx="1115568" cy="237744"/>
-          </a:xfrm>
-          <a:prstGeom prst="rect">
-            <a:avLst/>
-          </a:prstGeom>
-          <a:noFill/>
-        </p:spPr>
-        <p:txBody>
-          <a:bodyPr wrap="square">
-            <a:spAutoFit/>
-          </a:bodyPr>
-          <a:lstStyle/>
-          <a:p>
-            <a:pPr algn="ctr"/>
-            <a:r>
-              <a:rPr sz="850" b="1" i="0">
+            <a:off x="4654296" y="1554480"/>
+            <a:ext cx="1344168" cy="237744"/>
+          </a:xfrm>
+          <a:prstGeom prst="rect">
+            <a:avLst/>
+          </a:prstGeom>
+          <a:noFill/>
+        </p:spPr>
+        <p:txBody>
+          <a:bodyPr wrap="square">
+            <a:spAutoFit/>
+          </a:bodyPr>
+          <a:lstStyle/>
+          <a:p>
+            <a:pPr algn="ctr"/>
+            <a:r>
+              <a:rPr sz="800" b="1" i="0">
                 <a:solidFill>
                   <a:srgbClr val="FFFFFF"/>
                 </a:solidFill>
                 <a:latin typeface="Calibri"/>
               </a:rPr>
-              <a:t>Avg Freight</a:t>
+              <a:t>Avg Freight (INR)</a:t>
             </a:r>
           </a:p>
         </p:txBody>
@@ -18031,8 +18031,8 @@
         </p:nvSpPr>
         <p:spPr>
           <a:xfrm>
-            <a:off x="365760" y="1828800"/>
-            <a:ext cx="2377440" cy="429768"/>
+            <a:off x="365760" y="1847088"/>
+            <a:ext cx="2286000" cy="411480"/>
           </a:xfrm>
           <a:prstGeom prst="rect">
             <a:avLst/>
@@ -18074,8 +18074,8 @@
         </p:nvSpPr>
         <p:spPr>
           <a:xfrm>
-            <a:off x="402336" y="1883664"/>
-            <a:ext cx="2304288" cy="320040"/>
+            <a:off x="402336" y="1892807"/>
+            <a:ext cx="2212848" cy="320040"/>
           </a:xfrm>
           <a:prstGeom prst="rect">
             <a:avLst/>
@@ -18109,8 +18109,8 @@
         </p:nvSpPr>
         <p:spPr>
           <a:xfrm>
-            <a:off x="2743200" y="1828800"/>
-            <a:ext cx="731520" cy="429768"/>
+            <a:off x="2651760" y="1847088"/>
+            <a:ext cx="685800" cy="411480"/>
           </a:xfrm>
           <a:prstGeom prst="rect">
             <a:avLst/>
@@ -18152,8 +18152,8 @@
         </p:nvSpPr>
         <p:spPr>
           <a:xfrm>
-            <a:off x="2779776" y="1883664"/>
-            <a:ext cx="658368" cy="320040"/>
+            <a:off x="2688336" y="1892807"/>
+            <a:ext cx="612648" cy="320040"/>
           </a:xfrm>
           <a:prstGeom prst="rect">
             <a:avLst/>
@@ -18187,8 +18187,8 @@
         </p:nvSpPr>
         <p:spPr>
           <a:xfrm>
-            <a:off x="3474720" y="1828800"/>
-            <a:ext cx="640080" cy="429768"/>
+            <a:off x="3337560" y="1847088"/>
+            <a:ext cx="640080" cy="411480"/>
           </a:xfrm>
           <a:prstGeom prst="rect">
             <a:avLst/>
@@ -18230,7 +18230,7 @@
         </p:nvSpPr>
         <p:spPr>
           <a:xfrm>
-            <a:off x="3511296" y="1883664"/>
+            <a:off x="3374136" y="1892807"/>
             <a:ext cx="566928" cy="320040"/>
           </a:xfrm>
           <a:prstGeom prst="rect">
@@ -18265,8 +18265,8 @@
         </p:nvSpPr>
         <p:spPr>
           <a:xfrm>
-            <a:off x="4114800" y="1828800"/>
-            <a:ext cx="640080" cy="429768"/>
+            <a:off x="3977639" y="1847088"/>
+            <a:ext cx="640080" cy="411480"/>
           </a:xfrm>
           <a:prstGeom prst="rect">
             <a:avLst/>
@@ -18308,7 +18308,7 @@
         </p:nvSpPr>
         <p:spPr>
           <a:xfrm>
-            <a:off x="4151376" y="1883664"/>
+            <a:off x="4014215" y="1892807"/>
             <a:ext cx="566928" cy="320040"/>
           </a:xfrm>
           <a:prstGeom prst="rect">
@@ -18343,8 +18343,8 @@
         </p:nvSpPr>
         <p:spPr>
           <a:xfrm>
-            <a:off x="4754880" y="1828800"/>
-            <a:ext cx="1188720" cy="429768"/>
+            <a:off x="4617720" y="1847088"/>
+            <a:ext cx="1417320" cy="411480"/>
           </a:xfrm>
           <a:prstGeom prst="rect">
             <a:avLst/>
@@ -18386,8 +18386,8 @@
         </p:nvSpPr>
         <p:spPr>
           <a:xfrm>
-            <a:off x="4791456" y="1883664"/>
-            <a:ext cx="1115568" cy="320040"/>
+            <a:off x="4654296" y="1892807"/>
+            <a:ext cx="1344168" cy="320040"/>
           </a:xfrm>
           <a:prstGeom prst="rect">
             <a:avLst/>
@@ -18422,7 +18422,7 @@
         <p:spPr>
           <a:xfrm>
             <a:off x="365760" y="2304288"/>
-            <a:ext cx="2377440" cy="429768"/>
+            <a:ext cx="2286000" cy="411480"/>
           </a:xfrm>
           <a:prstGeom prst="rect">
             <a:avLst/>
@@ -18464,8 +18464,8 @@
         </p:nvSpPr>
         <p:spPr>
           <a:xfrm>
-            <a:off x="402336" y="2359152"/>
-            <a:ext cx="2304288" cy="320040"/>
+            <a:off x="402336" y="2350008"/>
+            <a:ext cx="2212848" cy="320040"/>
           </a:xfrm>
           <a:prstGeom prst="rect">
             <a:avLst/>
@@ -18499,8 +18499,8 @@
         </p:nvSpPr>
         <p:spPr>
           <a:xfrm>
-            <a:off x="2743200" y="2304288"/>
-            <a:ext cx="731520" cy="429768"/>
+            <a:off x="2651760" y="2304288"/>
+            <a:ext cx="685800" cy="411480"/>
           </a:xfrm>
           <a:prstGeom prst="rect">
             <a:avLst/>
@@ -18542,8 +18542,8 @@
         </p:nvSpPr>
         <p:spPr>
           <a:xfrm>
-            <a:off x="2779776" y="2359152"/>
-            <a:ext cx="658368" cy="320040"/>
+            <a:off x="2688336" y="2350008"/>
+            <a:ext cx="612648" cy="320040"/>
           </a:xfrm>
           <a:prstGeom prst="rect">
             <a:avLst/>
@@ -18577,8 +18577,8 @@
         </p:nvSpPr>
         <p:spPr>
           <a:xfrm>
-            <a:off x="3474720" y="2304288"/>
-            <a:ext cx="640080" cy="429768"/>
+            <a:off x="3337560" y="2304288"/>
+            <a:ext cx="640080" cy="411480"/>
           </a:xfrm>
           <a:prstGeom prst="rect">
             <a:avLst/>
@@ -18620,7 +18620,7 @@
         </p:nvSpPr>
         <p:spPr>
           <a:xfrm>
-            <a:off x="3511296" y="2359152"/>
+            <a:off x="3374136" y="2350008"/>
             <a:ext cx="566928" cy="320040"/>
           </a:xfrm>
           <a:prstGeom prst="rect">
@@ -18655,8 +18655,8 @@
         </p:nvSpPr>
         <p:spPr>
           <a:xfrm>
-            <a:off x="4114800" y="2304288"/>
-            <a:ext cx="640080" cy="429768"/>
+            <a:off x="3977639" y="2304288"/>
+            <a:ext cx="640080" cy="411480"/>
           </a:xfrm>
           <a:prstGeom prst="rect">
             <a:avLst/>
@@ -18698,7 +18698,7 @@
         </p:nvSpPr>
         <p:spPr>
           <a:xfrm>
-            <a:off x="4151376" y="2359152"/>
+            <a:off x="4014215" y="2350008"/>
             <a:ext cx="566928" cy="320040"/>
           </a:xfrm>
           <a:prstGeom prst="rect">
@@ -18733,8 +18733,8 @@
         </p:nvSpPr>
         <p:spPr>
           <a:xfrm>
-            <a:off x="4754880" y="2304288"/>
-            <a:ext cx="1188720" cy="429768"/>
+            <a:off x="4617720" y="2304288"/>
+            <a:ext cx="1417320" cy="411480"/>
           </a:xfrm>
           <a:prstGeom prst="rect">
             <a:avLst/>
@@ -18776,8 +18776,8 @@
         </p:nvSpPr>
         <p:spPr>
           <a:xfrm>
-            <a:off x="4791456" y="2359152"/>
-            <a:ext cx="1115568" cy="320040"/>
+            <a:off x="4654296" y="2350008"/>
+            <a:ext cx="1344168" cy="320040"/>
           </a:xfrm>
           <a:prstGeom prst="rect">
             <a:avLst/>
@@ -18811,8 +18811,8 @@
         </p:nvSpPr>
         <p:spPr>
           <a:xfrm>
-            <a:off x="365760" y="2779776"/>
-            <a:ext cx="2377440" cy="429768"/>
+            <a:off x="365760" y="2761488"/>
+            <a:ext cx="2286000" cy="411480"/>
           </a:xfrm>
           <a:prstGeom prst="rect">
             <a:avLst/>
@@ -18854,8 +18854,8 @@
         </p:nvSpPr>
         <p:spPr>
           <a:xfrm>
-            <a:off x="402336" y="2834640"/>
-            <a:ext cx="2304288" cy="320040"/>
+            <a:off x="402336" y="2807208"/>
+            <a:ext cx="2212848" cy="320040"/>
           </a:xfrm>
           <a:prstGeom prst="rect">
             <a:avLst/>
@@ -18889,8 +18889,8 @@
         </p:nvSpPr>
         <p:spPr>
           <a:xfrm>
-            <a:off x="2743200" y="2779776"/>
-            <a:ext cx="731520" cy="429768"/>
+            <a:off x="2651760" y="2761488"/>
+            <a:ext cx="685800" cy="411480"/>
           </a:xfrm>
           <a:prstGeom prst="rect">
             <a:avLst/>
@@ -18932,8 +18932,8 @@
         </p:nvSpPr>
         <p:spPr>
           <a:xfrm>
-            <a:off x="2779776" y="2834640"/>
-            <a:ext cx="658368" cy="320040"/>
+            <a:off x="2688336" y="2807208"/>
+            <a:ext cx="612648" cy="320040"/>
           </a:xfrm>
           <a:prstGeom prst="rect">
             <a:avLst/>
@@ -18967,8 +18967,8 @@
         </p:nvSpPr>
         <p:spPr>
           <a:xfrm>
-            <a:off x="3474720" y="2779776"/>
-            <a:ext cx="640080" cy="429768"/>
+            <a:off x="3337560" y="2761488"/>
+            <a:ext cx="640080" cy="411480"/>
           </a:xfrm>
           <a:prstGeom prst="rect">
             <a:avLst/>
@@ -19010,7 +19010,7 @@
         </p:nvSpPr>
         <p:spPr>
           <a:xfrm>
-            <a:off x="3511296" y="2834640"/>
+            <a:off x="3374136" y="2807208"/>
             <a:ext cx="566928" cy="320040"/>
           </a:xfrm>
           <a:prstGeom prst="rect">
@@ -19045,8 +19045,8 @@
         </p:nvSpPr>
         <p:spPr>
           <a:xfrm>
-            <a:off x="4114800" y="2779776"/>
-            <a:ext cx="640080" cy="429768"/>
+            <a:off x="3977639" y="2761488"/>
+            <a:ext cx="640080" cy="411480"/>
           </a:xfrm>
           <a:prstGeom prst="rect">
             <a:avLst/>
@@ -19088,7 +19088,7 @@
         </p:nvSpPr>
         <p:spPr>
           <a:xfrm>
-            <a:off x="4151376" y="2834640"/>
+            <a:off x="4014215" y="2807208"/>
             <a:ext cx="566928" cy="320040"/>
           </a:xfrm>
           <a:prstGeom prst="rect">
@@ -19123,8 +19123,8 @@
         </p:nvSpPr>
         <p:spPr>
           <a:xfrm>
-            <a:off x="4754880" y="2779776"/>
-            <a:ext cx="1188720" cy="429768"/>
+            <a:off x="4617720" y="2761488"/>
+            <a:ext cx="1417320" cy="411480"/>
           </a:xfrm>
           <a:prstGeom prst="rect">
             <a:avLst/>
@@ -19166,8 +19166,8 @@
         </p:nvSpPr>
         <p:spPr>
           <a:xfrm>
-            <a:off x="4791456" y="2834640"/>
-            <a:ext cx="1115568" cy="320040"/>
+            <a:off x="4654296" y="2807208"/>
+            <a:ext cx="1344168" cy="320040"/>
           </a:xfrm>
           <a:prstGeom prst="rect">
             <a:avLst/>
@@ -19201,8 +19201,8 @@
         </p:nvSpPr>
         <p:spPr>
           <a:xfrm>
-            <a:off x="365760" y="3255264"/>
-            <a:ext cx="2377440" cy="429768"/>
+            <a:off x="365760" y="3218688"/>
+            <a:ext cx="2286000" cy="411480"/>
           </a:xfrm>
           <a:prstGeom prst="rect">
             <a:avLst/>
@@ -19244,8 +19244,8 @@
         </p:nvSpPr>
         <p:spPr>
           <a:xfrm>
-            <a:off x="402336" y="3310128"/>
-            <a:ext cx="2304288" cy="320040"/>
+            <a:off x="402336" y="3264408"/>
+            <a:ext cx="2212848" cy="320040"/>
           </a:xfrm>
           <a:prstGeom prst="rect">
             <a:avLst/>
@@ -19279,8 +19279,8 @@
         </p:nvSpPr>
         <p:spPr>
           <a:xfrm>
-            <a:off x="2743200" y="3255264"/>
-            <a:ext cx="731520" cy="429768"/>
+            <a:off x="2651760" y="3218688"/>
+            <a:ext cx="685800" cy="411480"/>
           </a:xfrm>
           <a:prstGeom prst="rect">
             <a:avLst/>
@@ -19322,8 +19322,8 @@
         </p:nvSpPr>
         <p:spPr>
           <a:xfrm>
-            <a:off x="2779776" y="3310128"/>
-            <a:ext cx="658368" cy="320040"/>
+            <a:off x="2688336" y="3264408"/>
+            <a:ext cx="612648" cy="320040"/>
           </a:xfrm>
           <a:prstGeom prst="rect">
             <a:avLst/>
@@ -19357,8 +19357,8 @@
         </p:nvSpPr>
         <p:spPr>
           <a:xfrm>
-            <a:off x="3474720" y="3255264"/>
-            <a:ext cx="640080" cy="429768"/>
+            <a:off x="3337560" y="3218688"/>
+            <a:ext cx="640080" cy="411480"/>
           </a:xfrm>
           <a:prstGeom prst="rect">
             <a:avLst/>
@@ -19400,7 +19400,7 @@
         </p:nvSpPr>
         <p:spPr>
           <a:xfrm>
-            <a:off x="3511296" y="3310128"/>
+            <a:off x="3374136" y="3264408"/>
             <a:ext cx="566928" cy="320040"/>
           </a:xfrm>
           <a:prstGeom prst="rect">
@@ -19435,8 +19435,8 @@
         </p:nvSpPr>
         <p:spPr>
           <a:xfrm>
-            <a:off x="4114800" y="3255264"/>
-            <a:ext cx="640080" cy="429768"/>
+            <a:off x="3977639" y="3218688"/>
+            <a:ext cx="640080" cy="411480"/>
           </a:xfrm>
           <a:prstGeom prst="rect">
             <a:avLst/>
@@ -19478,7 +19478,7 @@
         </p:nvSpPr>
         <p:spPr>
           <a:xfrm>
-            <a:off x="4151376" y="3310128"/>
+            <a:off x="4014215" y="3264408"/>
             <a:ext cx="566928" cy="320040"/>
           </a:xfrm>
           <a:prstGeom prst="rect">
@@ -19513,8 +19513,8 @@
         </p:nvSpPr>
         <p:spPr>
           <a:xfrm>
-            <a:off x="4754880" y="3255264"/>
-            <a:ext cx="1188720" cy="429768"/>
+            <a:off x="4617720" y="3218688"/>
+            <a:ext cx="1417320" cy="411480"/>
           </a:xfrm>
           <a:prstGeom prst="rect">
             <a:avLst/>
@@ -19556,8 +19556,8 @@
         </p:nvSpPr>
         <p:spPr>
           <a:xfrm>
-            <a:off x="4791456" y="3310128"/>
-            <a:ext cx="1115568" cy="320040"/>
+            <a:off x="4654296" y="3264408"/>
+            <a:ext cx="1344168" cy="320040"/>
           </a:xfrm>
           <a:prstGeom prst="rect">
             <a:avLst/>
@@ -19591,8 +19591,8 @@
         </p:nvSpPr>
         <p:spPr>
           <a:xfrm>
-            <a:off x="6309360" y="1234440"/>
-            <a:ext cx="5486400" cy="256032"/>
+            <a:off x="6217920" y="1234440"/>
+            <a:ext cx="5760720" cy="256032"/>
           </a:xfrm>
           <a:prstGeom prst="rect">
             <a:avLst/>
@@ -19607,13 +19607,13 @@
           <a:p>
             <a:pPr algn="l"/>
             <a:r>
-              <a:rPr sz="1200" b="1" i="0">
+              <a:rPr sz="1100" b="1" i="0">
                 <a:solidFill>
                   <a:srgbClr val="1F3864"/>
                 </a:solidFill>
                 <a:latin typeface="Calibri"/>
               </a:rPr>
-              <a:t>Average Lead Time by Region</a:t>
+              <a:t>Avg Lead Time by Region (Days)</a:t>
             </a:r>
           </a:p>
         </p:txBody>
@@ -19626,8 +19626,8 @@
         </p:nvSpPr>
         <p:spPr>
           <a:xfrm>
-            <a:off x="6309360" y="1536192"/>
-            <a:ext cx="3657600" cy="530352"/>
+            <a:off x="6217920" y="1536192"/>
+            <a:ext cx="2377440" cy="530352"/>
           </a:xfrm>
           <a:prstGeom prst="rect">
             <a:avLst/>
@@ -19669,8 +19669,8 @@
         </p:nvSpPr>
         <p:spPr>
           <a:xfrm>
-            <a:off x="6355080" y="1627632"/>
-            <a:ext cx="2011680" cy="347472"/>
+            <a:off x="6263640" y="1627632"/>
+            <a:ext cx="2286000" cy="347472"/>
           </a:xfrm>
           <a:prstGeom prst="rect">
             <a:avLst/>
@@ -19704,8 +19704,8 @@
         </p:nvSpPr>
         <p:spPr>
           <a:xfrm>
-            <a:off x="8321040" y="1627632"/>
-            <a:ext cx="3200400" cy="347472"/>
+            <a:off x="8686800" y="1627632"/>
+            <a:ext cx="3840480" cy="347472"/>
           </a:xfrm>
           <a:prstGeom prst="rect">
             <a:avLst/>
@@ -19747,8 +19747,8 @@
         </p:nvSpPr>
         <p:spPr>
           <a:xfrm>
-            <a:off x="11567160" y="1645919"/>
-            <a:ext cx="731520" cy="310896"/>
+            <a:off x="11612880" y="1645919"/>
+            <a:ext cx="502920" cy="310896"/>
           </a:xfrm>
           <a:prstGeom prst="rect">
             <a:avLst/>
@@ -19782,8 +19782,8 @@
         </p:nvSpPr>
         <p:spPr>
           <a:xfrm>
-            <a:off x="6309360" y="2194560"/>
-            <a:ext cx="3657600" cy="530352"/>
+            <a:off x="6217920" y="2194560"/>
+            <a:ext cx="2377440" cy="530352"/>
           </a:xfrm>
           <a:prstGeom prst="rect">
             <a:avLst/>
@@ -19825,8 +19825,8 @@
         </p:nvSpPr>
         <p:spPr>
           <a:xfrm>
-            <a:off x="6355080" y="2286000"/>
-            <a:ext cx="2011680" cy="347472"/>
+            <a:off x="6263640" y="2286000"/>
+            <a:ext cx="2286000" cy="347472"/>
           </a:xfrm>
           <a:prstGeom prst="rect">
             <a:avLst/>
@@ -19860,8 +19860,8 @@
         </p:nvSpPr>
         <p:spPr>
           <a:xfrm>
-            <a:off x="8321040" y="2286000"/>
-            <a:ext cx="2615159" cy="347472"/>
+            <a:off x="8686800" y="2286000"/>
+            <a:ext cx="3138191" cy="347472"/>
           </a:xfrm>
           <a:prstGeom prst="rect">
             <a:avLst/>
@@ -19903,8 +19903,8 @@
         </p:nvSpPr>
         <p:spPr>
           <a:xfrm>
-            <a:off x="10981919" y="2304288"/>
-            <a:ext cx="731520" cy="310896"/>
+            <a:off x="11612880" y="2304288"/>
+            <a:ext cx="502920" cy="310896"/>
           </a:xfrm>
           <a:prstGeom prst="rect">
             <a:avLst/>
@@ -19938,8 +19938,8 @@
         </p:nvSpPr>
         <p:spPr>
           <a:xfrm>
-            <a:off x="6309360" y="2852928"/>
-            <a:ext cx="3657600" cy="530352"/>
+            <a:off x="6217920" y="2852928"/>
+            <a:ext cx="2377440" cy="530352"/>
           </a:xfrm>
           <a:prstGeom prst="rect">
             <a:avLst/>
@@ -19981,8 +19981,8 @@
         </p:nvSpPr>
         <p:spPr>
           <a:xfrm>
-            <a:off x="6355080" y="2944368"/>
-            <a:ext cx="2011680" cy="347472"/>
+            <a:off x="6263640" y="2944368"/>
+            <a:ext cx="2286000" cy="347472"/>
           </a:xfrm>
           <a:prstGeom prst="rect">
             <a:avLst/>
@@ -20016,8 +20016,8 @@
         </p:nvSpPr>
         <p:spPr>
           <a:xfrm>
-            <a:off x="8321040" y="2944368"/>
-            <a:ext cx="2573786" cy="347472"/>
+            <a:off x="8686800" y="2944368"/>
+            <a:ext cx="3088543" cy="347472"/>
           </a:xfrm>
           <a:prstGeom prst="rect">
             <a:avLst/>
@@ -20059,8 +20059,8 @@
         </p:nvSpPr>
         <p:spPr>
           <a:xfrm>
-            <a:off x="10940546" y="2962656"/>
-            <a:ext cx="731520" cy="310896"/>
+            <a:off x="11612880" y="2962656"/>
+            <a:ext cx="502920" cy="310896"/>
           </a:xfrm>
           <a:prstGeom prst="rect">
             <a:avLst/>
@@ -20094,8 +20094,8 @@
         </p:nvSpPr>
         <p:spPr>
           <a:xfrm>
-            <a:off x="6309360" y="3511296"/>
-            <a:ext cx="3657600" cy="530352"/>
+            <a:off x="6217920" y="3511296"/>
+            <a:ext cx="2377440" cy="530352"/>
           </a:xfrm>
           <a:prstGeom prst="rect">
             <a:avLst/>
@@ -20137,8 +20137,8 @@
         </p:nvSpPr>
         <p:spPr>
           <a:xfrm>
-            <a:off x="6355080" y="3602736"/>
-            <a:ext cx="2011680" cy="347472"/>
+            <a:off x="6263640" y="3602736"/>
+            <a:ext cx="2286000" cy="347472"/>
           </a:xfrm>
           <a:prstGeom prst="rect">
             <a:avLst/>
@@ -20172,8 +20172,8 @@
         </p:nvSpPr>
         <p:spPr>
           <a:xfrm>
-            <a:off x="8321040" y="3602736"/>
-            <a:ext cx="2088280" cy="347472"/>
+            <a:off x="8686800" y="3602736"/>
+            <a:ext cx="2505936" cy="347472"/>
           </a:xfrm>
           <a:prstGeom prst="rect">
             <a:avLst/>
@@ -20215,8 +20215,8 @@
         </p:nvSpPr>
         <p:spPr>
           <a:xfrm>
-            <a:off x="10455040" y="3621024"/>
-            <a:ext cx="731520" cy="310896"/>
+            <a:off x="11238456" y="3621024"/>
+            <a:ext cx="502920" cy="310896"/>
           </a:xfrm>
           <a:prstGeom prst="rect">
             <a:avLst/>
@@ -20250,8 +20250,8 @@
         </p:nvSpPr>
         <p:spPr>
           <a:xfrm>
-            <a:off x="6309360" y="4169663"/>
-            <a:ext cx="3657600" cy="530352"/>
+            <a:off x="6217920" y="4169663"/>
+            <a:ext cx="2377440" cy="530352"/>
           </a:xfrm>
           <a:prstGeom prst="rect">
             <a:avLst/>
@@ -20293,8 +20293,8 @@
         </p:nvSpPr>
         <p:spPr>
           <a:xfrm>
-            <a:off x="6355080" y="4261103"/>
-            <a:ext cx="2011680" cy="347472"/>
+            <a:off x="6263640" y="4261103"/>
+            <a:ext cx="2286000" cy="347472"/>
           </a:xfrm>
           <a:prstGeom prst="rect">
             <a:avLst/>
@@ -20328,8 +20328,8 @@
         </p:nvSpPr>
         <p:spPr>
           <a:xfrm>
-            <a:off x="8321040" y="4261103"/>
-            <a:ext cx="2050530" cy="347472"/>
+            <a:off x="8686800" y="4261103"/>
+            <a:ext cx="2460636" cy="347472"/>
           </a:xfrm>
           <a:prstGeom prst="rect">
             <a:avLst/>
@@ -20371,8 +20371,8 @@
         </p:nvSpPr>
         <p:spPr>
           <a:xfrm>
-            <a:off x="10417290" y="4279392"/>
-            <a:ext cx="731520" cy="310896"/>
+            <a:off x="11193156" y="4279392"/>
+            <a:ext cx="502920" cy="310896"/>
           </a:xfrm>
           <a:prstGeom prst="rect">
             <a:avLst/>
@@ -20406,8 +20406,8 @@
         </p:nvSpPr>
         <p:spPr>
           <a:xfrm>
-            <a:off x="365760" y="4023360"/>
-            <a:ext cx="11430000" cy="256032"/>
+            <a:off x="365760" y="4754880"/>
+            <a:ext cx="11612880" cy="256032"/>
           </a:xfrm>
           <a:prstGeom prst="rect">
             <a:avLst/>
@@ -20422,7 +20422,7 @@
           <a:p>
             <a:pPr algn="l"/>
             <a:r>
-              <a:rPr sz="1200" b="1" i="0">
+              <a:rPr sz="1100" b="1" i="0">
                 <a:solidFill>
                   <a:srgbClr val="1F3864"/>
                 </a:solidFill>
@@ -20441,8 +20441,8 @@
         </p:nvSpPr>
         <p:spPr>
           <a:xfrm>
-            <a:off x="365760" y="4315968"/>
-            <a:ext cx="11430000" cy="1920240"/>
+            <a:off x="365760" y="5047488"/>
+            <a:ext cx="11612880" cy="1600200"/>
           </a:xfrm>
           <a:prstGeom prst="rect">
             <a:avLst/>
@@ -20484,8 +20484,8 @@
         </p:nvSpPr>
         <p:spPr>
           <a:xfrm>
-            <a:off x="457200" y="4389120"/>
-            <a:ext cx="11247120" cy="1828800"/>
+            <a:off x="457200" y="5120640"/>
+            <a:ext cx="11430000" cy="1508760"/>
           </a:xfrm>
           <a:prstGeom prst="rect">
             <a:avLst/>
@@ -20510,7 +20510,7 @@
                 </a:solidFill>
                 <a:latin typeface="Calibri"/>
               </a:rPr>
-              <a:t>  •  Air Freight has 1-day lead time but costs 3x more than Road — recommended only for urgent/high-value orders</a:t>
+              <a:t>  •  Air Freight has 1-day lead time but costs 3x more than Road — use only for urgent/high-value orders</a:t>
             </a:r>
           </a:p>
           <a:p>
@@ -20526,7 +20526,7 @@
                 </a:solidFill>
                 <a:latin typeface="Calibri"/>
               </a:rPr>
-              <a:t>  •  East India consistently shows highest lead times (5–7 days) — hub consolidation recommended in Kolkata</a:t>
+              <a:t>  •  East India has highest avg lead time (5–7 days) — Kolkata hub consolidation recommended</a:t>
             </a:r>
           </a:p>
           <a:p>
@@ -20542,7 +20542,7 @@
                 </a:solidFill>
                 <a:latin typeface="Calibri"/>
               </a:rPr>
-              <a:t>  •  Road (Truck) handles 55% of shipments — optimizing truck routing could cut freight cost by 12–18%</a:t>
+              <a:t>  •  Road (Truck) handles 55% of shipments — route optimization could cut freight cost by 12–18%</a:t>
             </a:r>
           </a:p>
           <a:p>
@@ -20558,7 +20558,7 @@
                 </a:solidFill>
                 <a:latin typeface="Calibri"/>
               </a:rPr>
-              <a:t>  •  Rail Freight underutilized at 15% — expanding rail for bulk lager SKUs could save INR 15–20L annually</a:t>
+              <a:t>  •  Rail Freight underutilized at 15% — expanding to bulk Lager SKUs could save INR 15–20L/yr</a:t>
             </a:r>
           </a:p>
         </p:txBody>
@@ -21744,7 +21744,7 @@
         <p:spPr>
           <a:xfrm>
             <a:off x="365760" y="3429000"/>
-            <a:ext cx="5486400" cy="256032"/>
+            <a:ext cx="5303520" cy="256032"/>
           </a:xfrm>
           <a:prstGeom prst="rect">
             <a:avLst/>
@@ -21765,7 +21765,7 @@
                 </a:solidFill>
                 <a:latin typeface="Calibri"/>
               </a:rPr>
-              <a:t>OTIF by Channel</a:t>
+              <a:t>OTIF by Distribution Channel</a:t>
             </a:r>
           </a:p>
         </p:txBody>
@@ -21778,8 +21778,8 @@
         </p:nvSpPr>
         <p:spPr>
           <a:xfrm>
-            <a:off x="365760" y="3730752"/>
-            <a:ext cx="2651760" cy="914400"/>
+            <a:off x="365760" y="3794760"/>
+            <a:ext cx="2468880" cy="1051560"/>
           </a:xfrm>
           <a:prstGeom prst="rect">
             <a:avLst/>
@@ -21821,23 +21821,23 @@
         </p:nvSpPr>
         <p:spPr>
           <a:xfrm>
-            <a:off x="457200" y="3767328"/>
-            <a:ext cx="2468880" cy="347472"/>
-          </a:xfrm>
-          <a:prstGeom prst="rect">
-            <a:avLst/>
-          </a:prstGeom>
-          <a:noFill/>
-        </p:spPr>
-        <p:txBody>
-          <a:bodyPr wrap="square">
-            <a:spAutoFit/>
-          </a:bodyPr>
-          <a:lstStyle/>
-          <a:p>
-            <a:pPr algn="ctr"/>
-            <a:r>
-              <a:rPr sz="900" b="1" i="0">
+            <a:off x="457200" y="3886200"/>
+            <a:ext cx="2286000" cy="320040"/>
+          </a:xfrm>
+          <a:prstGeom prst="rect">
+            <a:avLst/>
+          </a:prstGeom>
+          <a:noFill/>
+        </p:spPr>
+        <p:txBody>
+          <a:bodyPr wrap="square">
+            <a:spAutoFit/>
+          </a:bodyPr>
+          <a:lstStyle/>
+          <a:p>
+            <a:pPr algn="ctr"/>
+            <a:r>
+              <a:rPr sz="950" b="1" i="0">
                 <a:solidFill>
                   <a:srgbClr val="FFFFFF"/>
                 </a:solidFill>
@@ -21856,23 +21856,23 @@
         </p:nvSpPr>
         <p:spPr>
           <a:xfrm>
-            <a:off x="457200" y="4096512"/>
-            <a:ext cx="2468880" cy="438912"/>
-          </a:xfrm>
-          <a:prstGeom prst="rect">
-            <a:avLst/>
-          </a:prstGeom>
-          <a:noFill/>
-        </p:spPr>
-        <p:txBody>
-          <a:bodyPr wrap="square">
-            <a:spAutoFit/>
-          </a:bodyPr>
-          <a:lstStyle/>
-          <a:p>
-            <a:pPr algn="ctr"/>
-            <a:r>
-              <a:rPr sz="2000" b="1" i="0">
+            <a:off x="457200" y="4206240"/>
+            <a:ext cx="2286000" cy="502920"/>
+          </a:xfrm>
+          <a:prstGeom prst="rect">
+            <a:avLst/>
+          </a:prstGeom>
+          <a:noFill/>
+        </p:spPr>
+        <p:txBody>
+          <a:bodyPr wrap="square">
+            <a:spAutoFit/>
+          </a:bodyPr>
+          <a:lstStyle/>
+          <a:p>
+            <a:pPr algn="ctr"/>
+            <a:r>
+              <a:rPr sz="2200" b="1" i="0">
                 <a:solidFill>
                   <a:srgbClr val="FFFFFF"/>
                 </a:solidFill>
@@ -21891,8 +21891,8 @@
         </p:nvSpPr>
         <p:spPr>
           <a:xfrm>
-            <a:off x="3200400" y="3730752"/>
-            <a:ext cx="2651760" cy="914400"/>
+            <a:off x="3017520" y="3794760"/>
+            <a:ext cx="2468880" cy="1051560"/>
           </a:xfrm>
           <a:prstGeom prst="rect">
             <a:avLst/>
@@ -21934,23 +21934,23 @@
         </p:nvSpPr>
         <p:spPr>
           <a:xfrm>
-            <a:off x="3291840" y="3767328"/>
-            <a:ext cx="2468880" cy="347472"/>
-          </a:xfrm>
-          <a:prstGeom prst="rect">
-            <a:avLst/>
-          </a:prstGeom>
-          <a:noFill/>
-        </p:spPr>
-        <p:txBody>
-          <a:bodyPr wrap="square">
-            <a:spAutoFit/>
-          </a:bodyPr>
-          <a:lstStyle/>
-          <a:p>
-            <a:pPr algn="ctr"/>
-            <a:r>
-              <a:rPr sz="900" b="1" i="0">
+            <a:off x="3108960" y="3886200"/>
+            <a:ext cx="2286000" cy="320040"/>
+          </a:xfrm>
+          <a:prstGeom prst="rect">
+            <a:avLst/>
+          </a:prstGeom>
+          <a:noFill/>
+        </p:spPr>
+        <p:txBody>
+          <a:bodyPr wrap="square">
+            <a:spAutoFit/>
+          </a:bodyPr>
+          <a:lstStyle/>
+          <a:p>
+            <a:pPr algn="ctr"/>
+            <a:r>
+              <a:rPr sz="950" b="1" i="0">
                 <a:solidFill>
                   <a:srgbClr val="FFFFFF"/>
                 </a:solidFill>
@@ -21969,23 +21969,23 @@
         </p:nvSpPr>
         <p:spPr>
           <a:xfrm>
-            <a:off x="3291840" y="4096512"/>
-            <a:ext cx="2468880" cy="438912"/>
-          </a:xfrm>
-          <a:prstGeom prst="rect">
-            <a:avLst/>
-          </a:prstGeom>
-          <a:noFill/>
-        </p:spPr>
-        <p:txBody>
-          <a:bodyPr wrap="square">
-            <a:spAutoFit/>
-          </a:bodyPr>
-          <a:lstStyle/>
-          <a:p>
-            <a:pPr algn="ctr"/>
-            <a:r>
-              <a:rPr sz="2000" b="1" i="0">
+            <a:off x="3108960" y="4206240"/>
+            <a:ext cx="2286000" cy="502920"/>
+          </a:xfrm>
+          <a:prstGeom prst="rect">
+            <a:avLst/>
+          </a:prstGeom>
+          <a:noFill/>
+        </p:spPr>
+        <p:txBody>
+          <a:bodyPr wrap="square">
+            <a:spAutoFit/>
+          </a:bodyPr>
+          <a:lstStyle/>
+          <a:p>
+            <a:pPr algn="ctr"/>
+            <a:r>
+              <a:rPr sz="2200" b="1" i="0">
                 <a:solidFill>
                   <a:srgbClr val="FFFFFF"/>
                 </a:solidFill>
@@ -22004,8 +22004,8 @@
         </p:nvSpPr>
         <p:spPr>
           <a:xfrm>
-            <a:off x="6035040" y="3730752"/>
-            <a:ext cx="2651760" cy="914400"/>
+            <a:off x="365760" y="4983480"/>
+            <a:ext cx="2468880" cy="1051560"/>
           </a:xfrm>
           <a:prstGeom prst="rect">
             <a:avLst/>
@@ -22047,23 +22047,23 @@
         </p:nvSpPr>
         <p:spPr>
           <a:xfrm>
-            <a:off x="6126480" y="3767328"/>
-            <a:ext cx="2468880" cy="347472"/>
-          </a:xfrm>
-          <a:prstGeom prst="rect">
-            <a:avLst/>
-          </a:prstGeom>
-          <a:noFill/>
-        </p:spPr>
-        <p:txBody>
-          <a:bodyPr wrap="square">
-            <a:spAutoFit/>
-          </a:bodyPr>
-          <a:lstStyle/>
-          <a:p>
-            <a:pPr algn="ctr"/>
-            <a:r>
-              <a:rPr sz="900" b="1" i="0">
+            <a:off x="457200" y="5074920"/>
+            <a:ext cx="2286000" cy="320040"/>
+          </a:xfrm>
+          <a:prstGeom prst="rect">
+            <a:avLst/>
+          </a:prstGeom>
+          <a:noFill/>
+        </p:spPr>
+        <p:txBody>
+          <a:bodyPr wrap="square">
+            <a:spAutoFit/>
+          </a:bodyPr>
+          <a:lstStyle/>
+          <a:p>
+            <a:pPr algn="ctr"/>
+            <a:r>
+              <a:rPr sz="950" b="1" i="0">
                 <a:solidFill>
                   <a:srgbClr val="FFFFFF"/>
                 </a:solidFill>
@@ -22082,23 +22082,23 @@
         </p:nvSpPr>
         <p:spPr>
           <a:xfrm>
-            <a:off x="6126480" y="4096512"/>
-            <a:ext cx="2468880" cy="438912"/>
-          </a:xfrm>
-          <a:prstGeom prst="rect">
-            <a:avLst/>
-          </a:prstGeom>
-          <a:noFill/>
-        </p:spPr>
-        <p:txBody>
-          <a:bodyPr wrap="square">
-            <a:spAutoFit/>
-          </a:bodyPr>
-          <a:lstStyle/>
-          <a:p>
-            <a:pPr algn="ctr"/>
-            <a:r>
-              <a:rPr sz="2000" b="1" i="0">
+            <a:off x="457200" y="5394960"/>
+            <a:ext cx="2286000" cy="502920"/>
+          </a:xfrm>
+          <a:prstGeom prst="rect">
+            <a:avLst/>
+          </a:prstGeom>
+          <a:noFill/>
+        </p:spPr>
+        <p:txBody>
+          <a:bodyPr wrap="square">
+            <a:spAutoFit/>
+          </a:bodyPr>
+          <a:lstStyle/>
+          <a:p>
+            <a:pPr algn="ctr"/>
+            <a:r>
+              <a:rPr sz="2200" b="1" i="0">
                 <a:solidFill>
                   <a:srgbClr val="FFFFFF"/>
                 </a:solidFill>
@@ -22117,8 +22117,8 @@
         </p:nvSpPr>
         <p:spPr>
           <a:xfrm>
-            <a:off x="8869680" y="3730752"/>
-            <a:ext cx="2651760" cy="914400"/>
+            <a:off x="3017520" y="4983480"/>
+            <a:ext cx="2468880" cy="1051560"/>
           </a:xfrm>
           <a:prstGeom prst="rect">
             <a:avLst/>
@@ -22160,23 +22160,23 @@
         </p:nvSpPr>
         <p:spPr>
           <a:xfrm>
-            <a:off x="8961120" y="3767328"/>
-            <a:ext cx="2468880" cy="347472"/>
-          </a:xfrm>
-          <a:prstGeom prst="rect">
-            <a:avLst/>
-          </a:prstGeom>
-          <a:noFill/>
-        </p:spPr>
-        <p:txBody>
-          <a:bodyPr wrap="square">
-            <a:spAutoFit/>
-          </a:bodyPr>
-          <a:lstStyle/>
-          <a:p>
-            <a:pPr algn="ctr"/>
-            <a:r>
-              <a:rPr sz="900" b="1" i="0">
+            <a:off x="3108960" y="5074920"/>
+            <a:ext cx="2286000" cy="320040"/>
+          </a:xfrm>
+          <a:prstGeom prst="rect">
+            <a:avLst/>
+          </a:prstGeom>
+          <a:noFill/>
+        </p:spPr>
+        <p:txBody>
+          <a:bodyPr wrap="square">
+            <a:spAutoFit/>
+          </a:bodyPr>
+          <a:lstStyle/>
+          <a:p>
+            <a:pPr algn="ctr"/>
+            <a:r>
+              <a:rPr sz="950" b="1" i="0">
                 <a:solidFill>
                   <a:srgbClr val="FFFFFF"/>
                 </a:solidFill>
@@ -22195,23 +22195,23 @@
         </p:nvSpPr>
         <p:spPr>
           <a:xfrm>
-            <a:off x="8961120" y="4096512"/>
-            <a:ext cx="2468880" cy="438912"/>
-          </a:xfrm>
-          <a:prstGeom prst="rect">
-            <a:avLst/>
-          </a:prstGeom>
-          <a:noFill/>
-        </p:spPr>
-        <p:txBody>
-          <a:bodyPr wrap="square">
-            <a:spAutoFit/>
-          </a:bodyPr>
-          <a:lstStyle/>
-          <a:p>
-            <a:pPr algn="ctr"/>
-            <a:r>
-              <a:rPr sz="2000" b="1" i="0">
+            <a:off x="3108960" y="5394960"/>
+            <a:ext cx="2286000" cy="502920"/>
+          </a:xfrm>
+          <a:prstGeom prst="rect">
+            <a:avLst/>
+          </a:prstGeom>
+          <a:noFill/>
+        </p:spPr>
+        <p:txBody>
+          <a:bodyPr wrap="square">
+            <a:spAutoFit/>
+          </a:bodyPr>
+          <a:lstStyle/>
+          <a:p>
+            <a:pPr algn="ctr"/>
+            <a:r>
+              <a:rPr sz="2200" b="1" i="0">
                 <a:solidFill>
                   <a:srgbClr val="FFFFFF"/>
                 </a:solidFill>
@@ -22231,7 +22231,7 @@
         <p:spPr>
           <a:xfrm>
             <a:off x="6035040" y="3429000"/>
-            <a:ext cx="5943600" cy="256032"/>
+            <a:ext cx="5669280" cy="256032"/>
           </a:xfrm>
           <a:prstGeom prst="rect">
             <a:avLst/>
@@ -22265,8 +22265,8 @@
         </p:nvSpPr>
         <p:spPr>
           <a:xfrm>
-            <a:off x="6035040" y="3730752"/>
-            <a:ext cx="3657600" cy="438912"/>
+            <a:off x="6035040" y="3794760"/>
+            <a:ext cx="2651760" cy="420624"/>
           </a:xfrm>
           <a:prstGeom prst="rect">
             <a:avLst/>
@@ -22308,8 +22308,8 @@
         </p:nvSpPr>
         <p:spPr>
           <a:xfrm>
-            <a:off x="6080760" y="3803904"/>
-            <a:ext cx="2743200" cy="292608"/>
+            <a:off x="6080760" y="3849624"/>
+            <a:ext cx="2560320" cy="310896"/>
           </a:xfrm>
           <a:prstGeom prst="rect">
             <a:avLst/>
@@ -22324,7 +22324,7 @@
           <a:p>
             <a:pPr algn="l"/>
             <a:r>
-              <a:rPr sz="900" b="0" i="0">
+              <a:rPr sz="850" b="0" i="0">
                 <a:solidFill>
                   <a:srgbClr val="262626"/>
                 </a:solidFill>
@@ -22343,8 +22343,8 @@
         </p:nvSpPr>
         <p:spPr>
           <a:xfrm>
-            <a:off x="8869680" y="3803904"/>
-            <a:ext cx="1120139" cy="292608"/>
+            <a:off x="8778240" y="3849624"/>
+            <a:ext cx="1840229" cy="310896"/>
           </a:xfrm>
           <a:prstGeom prst="rect">
             <a:avLst/>
@@ -22386,8 +22386,8 @@
         </p:nvSpPr>
         <p:spPr>
           <a:xfrm>
-            <a:off x="9235440" y="3803904"/>
-            <a:ext cx="640080" cy="292608"/>
+            <a:off x="10664190" y="3849624"/>
+            <a:ext cx="548640" cy="310896"/>
           </a:xfrm>
           <a:prstGeom prst="rect">
             <a:avLst/>
@@ -22402,7 +22402,7 @@
           <a:p>
             <a:pPr algn="l"/>
             <a:r>
-              <a:rPr sz="900" b="1" i="0">
+              <a:rPr sz="850" b="1" i="0">
                 <a:solidFill>
                   <a:srgbClr val="1F3864"/>
                 </a:solidFill>
@@ -22421,8 +22421,8 @@
         </p:nvSpPr>
         <p:spPr>
           <a:xfrm>
-            <a:off x="6035040" y="4261104"/>
-            <a:ext cx="3657600" cy="438912"/>
+            <a:off x="6035040" y="4288536"/>
+            <a:ext cx="2651760" cy="420624"/>
           </a:xfrm>
           <a:prstGeom prst="rect">
             <a:avLst/>
@@ -22464,8 +22464,8 @@
         </p:nvSpPr>
         <p:spPr>
           <a:xfrm>
-            <a:off x="6080760" y="4334256"/>
-            <a:ext cx="2743200" cy="292608"/>
+            <a:off x="6080760" y="4343400"/>
+            <a:ext cx="2560320" cy="310896"/>
           </a:xfrm>
           <a:prstGeom prst="rect">
             <a:avLst/>
@@ -22480,7 +22480,7 @@
           <a:p>
             <a:pPr algn="l"/>
             <a:r>
-              <a:rPr sz="900" b="0" i="0">
+              <a:rPr sz="850" b="0" i="0">
                 <a:solidFill>
                   <a:srgbClr val="262626"/>
                 </a:solidFill>
@@ -22499,8 +22499,8 @@
         </p:nvSpPr>
         <p:spPr>
           <a:xfrm>
-            <a:off x="8869680" y="4334256"/>
-            <a:ext cx="896112" cy="292608"/>
+            <a:off x="8778240" y="4343400"/>
+            <a:ext cx="1472184" cy="310896"/>
           </a:xfrm>
           <a:prstGeom prst="rect">
             <a:avLst/>
@@ -22542,8 +22542,8 @@
         </p:nvSpPr>
         <p:spPr>
           <a:xfrm>
-            <a:off x="9235440" y="4334256"/>
-            <a:ext cx="640080" cy="292608"/>
+            <a:off x="10296144" y="4343400"/>
+            <a:ext cx="548640" cy="310896"/>
           </a:xfrm>
           <a:prstGeom prst="rect">
             <a:avLst/>
@@ -22558,7 +22558,7 @@
           <a:p>
             <a:pPr algn="l"/>
             <a:r>
-              <a:rPr sz="900" b="1" i="0">
+              <a:rPr sz="850" b="1" i="0">
                 <a:solidFill>
                   <a:srgbClr val="1F3864"/>
                 </a:solidFill>
@@ -22577,8 +22577,8 @@
         </p:nvSpPr>
         <p:spPr>
           <a:xfrm>
-            <a:off x="6035040" y="4791456"/>
-            <a:ext cx="3657600" cy="438912"/>
+            <a:off x="6035040" y="4782312"/>
+            <a:ext cx="2651760" cy="420624"/>
           </a:xfrm>
           <a:prstGeom prst="rect">
             <a:avLst/>
@@ -22620,8 +22620,8 @@
         </p:nvSpPr>
         <p:spPr>
           <a:xfrm>
-            <a:off x="6080760" y="4864608"/>
-            <a:ext cx="2743200" cy="292608"/>
+            <a:off x="6080760" y="4837176"/>
+            <a:ext cx="2560320" cy="310896"/>
           </a:xfrm>
           <a:prstGeom prst="rect">
             <a:avLst/>
@@ -22636,7 +22636,7 @@
           <a:p>
             <a:pPr algn="l"/>
             <a:r>
-              <a:rPr sz="900" b="0" i="0">
+              <a:rPr sz="850" b="0" i="0">
                 <a:solidFill>
                   <a:srgbClr val="262626"/>
                 </a:solidFill>
@@ -22655,8 +22655,8 @@
         </p:nvSpPr>
         <p:spPr>
           <a:xfrm>
-            <a:off x="8869680" y="4864608"/>
-            <a:ext cx="576072" cy="292608"/>
+            <a:off x="8778240" y="4837176"/>
+            <a:ext cx="946403" cy="310896"/>
           </a:xfrm>
           <a:prstGeom prst="rect">
             <a:avLst/>
@@ -22698,8 +22698,8 @@
         </p:nvSpPr>
         <p:spPr>
           <a:xfrm>
-            <a:off x="9235440" y="4864608"/>
-            <a:ext cx="640080" cy="292608"/>
+            <a:off x="9770364" y="4837176"/>
+            <a:ext cx="548640" cy="310896"/>
           </a:xfrm>
           <a:prstGeom prst="rect">
             <a:avLst/>
@@ -22714,7 +22714,7 @@
           <a:p>
             <a:pPr algn="l"/>
             <a:r>
-              <a:rPr sz="900" b="1" i="0">
+              <a:rPr sz="850" b="1" i="0">
                 <a:solidFill>
                   <a:srgbClr val="1F3864"/>
                 </a:solidFill>
@@ -22733,8 +22733,8 @@
         </p:nvSpPr>
         <p:spPr>
           <a:xfrm>
-            <a:off x="6035040" y="5321808"/>
-            <a:ext cx="3657600" cy="438912"/>
+            <a:off x="6035040" y="5276088"/>
+            <a:ext cx="2651760" cy="420624"/>
           </a:xfrm>
           <a:prstGeom prst="rect">
             <a:avLst/>
@@ -22776,8 +22776,8 @@
         </p:nvSpPr>
         <p:spPr>
           <a:xfrm>
-            <a:off x="6080760" y="5394960"/>
-            <a:ext cx="2743200" cy="292608"/>
+            <a:off x="6080760" y="5330952"/>
+            <a:ext cx="2560320" cy="310896"/>
           </a:xfrm>
           <a:prstGeom prst="rect">
             <a:avLst/>
@@ -22792,7 +22792,7 @@
           <a:p>
             <a:pPr algn="l"/>
             <a:r>
-              <a:rPr sz="900" b="0" i="0">
+              <a:rPr sz="850" b="0" i="0">
                 <a:solidFill>
                   <a:srgbClr val="262626"/>
                 </a:solidFill>
@@ -22811,8 +22811,8 @@
         </p:nvSpPr>
         <p:spPr>
           <a:xfrm>
-            <a:off x="8869680" y="5394960"/>
-            <a:ext cx="384048" cy="292608"/>
+            <a:off x="8778240" y="5330952"/>
+            <a:ext cx="630936" cy="310896"/>
           </a:xfrm>
           <a:prstGeom prst="rect">
             <a:avLst/>
@@ -22854,8 +22854,8 @@
         </p:nvSpPr>
         <p:spPr>
           <a:xfrm>
-            <a:off x="9235440" y="5394960"/>
-            <a:ext cx="640080" cy="292608"/>
+            <a:off x="9454896" y="5330952"/>
+            <a:ext cx="548640" cy="310896"/>
           </a:xfrm>
           <a:prstGeom prst="rect">
             <a:avLst/>
@@ -22870,7 +22870,7 @@
           <a:p>
             <a:pPr algn="l"/>
             <a:r>
-              <a:rPr sz="900" b="1" i="0">
+              <a:rPr sz="850" b="1" i="0">
                 <a:solidFill>
                   <a:srgbClr val="1F3864"/>
                 </a:solidFill>
@@ -22889,8 +22889,8 @@
         </p:nvSpPr>
         <p:spPr>
           <a:xfrm>
-            <a:off x="6035040" y="5852160"/>
-            <a:ext cx="3657600" cy="438912"/>
+            <a:off x="6035040" y="5769864"/>
+            <a:ext cx="2651760" cy="420624"/>
           </a:xfrm>
           <a:prstGeom prst="rect">
             <a:avLst/>
@@ -22932,8 +22932,8 @@
         </p:nvSpPr>
         <p:spPr>
           <a:xfrm>
-            <a:off x="6080760" y="5925312"/>
-            <a:ext cx="2743200" cy="292608"/>
+            <a:off x="6080760" y="5824728"/>
+            <a:ext cx="2560320" cy="310896"/>
           </a:xfrm>
           <a:prstGeom prst="rect">
             <a:avLst/>
@@ -22948,7 +22948,7 @@
           <a:p>
             <a:pPr algn="l"/>
             <a:r>
-              <a:rPr sz="900" b="0" i="0">
+              <a:rPr sz="850" b="0" i="0">
                 <a:solidFill>
                   <a:srgbClr val="262626"/>
                 </a:solidFill>
@@ -22967,8 +22967,8 @@
         </p:nvSpPr>
         <p:spPr>
           <a:xfrm>
-            <a:off x="8869680" y="5925312"/>
-            <a:ext cx="224028" cy="292608"/>
+            <a:off x="8778240" y="5824728"/>
+            <a:ext cx="368046" cy="310896"/>
           </a:xfrm>
           <a:prstGeom prst="rect">
             <a:avLst/>
@@ -23010,8 +23010,8 @@
         </p:nvSpPr>
         <p:spPr>
           <a:xfrm>
-            <a:off x="9235440" y="5925312"/>
-            <a:ext cx="640080" cy="292608"/>
+            <a:off x="9192006" y="5824728"/>
+            <a:ext cx="548640" cy="310896"/>
           </a:xfrm>
           <a:prstGeom prst="rect">
             <a:avLst/>
@@ -23026,7 +23026,7 @@
           <a:p>
             <a:pPr algn="l"/>
             <a:r>
-              <a:rPr sz="900" b="1" i="0">
+              <a:rPr sz="850" b="1" i="0">
                 <a:solidFill>
                   <a:srgbClr val="1F3864"/>
                 </a:solidFill>

</xml_diff>